<commit_message>
Remove student name placeholders from presentation
Co-Authored-By: Claude Sonnet 4.6 <noreply@anthropic.com>
</commit_message>
<xml_diff>
--- a/Assignment2_Presentation.pptx
+++ b/Assignment2_Presentation.pptx
@@ -3454,7 +3454,7 @@
                 </a:solidFill>
                 <a:latin typeface="Calibri"/>
               </a:rPr>
-              <a:t>Group Members: [Student 1]  |  [Student 2]  |  [Student 3]</a:t>
+              <a:t>Group Assignment 2</a:t>
             </a:r>
           </a:p>
         </p:txBody>
@@ -21210,29 +21210,29 @@
         </p:nvSpPr>
         <p:spPr>
           <a:xfrm>
-            <a:off x="365760" y="2788920"/>
-            <a:ext cx="11430000" cy="365760"/>
-          </a:xfrm>
-          <a:prstGeom prst="rect">
-            <a:avLst/>
-          </a:prstGeom>
-          <a:noFill/>
-        </p:spPr>
-        <p:txBody>
-          <a:bodyPr wrap="square">
-            <a:spAutoFit/>
-          </a:bodyPr>
-          <a:lstStyle/>
-          <a:p>
-            <a:pPr algn="ctr"/>
-            <a:r>
-              <a:rPr sz="1700" b="1" i="0">
-                <a:solidFill>
-                  <a:srgbClr val="00B4D8"/>
-                </a:solidFill>
-                <a:latin typeface="Calibri"/>
-              </a:rPr>
-              <a:t>Presented by:</a:t>
+            <a:off x="365760" y="3017520"/>
+            <a:ext cx="11430000" cy="502920"/>
+          </a:xfrm>
+          <a:prstGeom prst="rect">
+            <a:avLst/>
+          </a:prstGeom>
+          <a:noFill/>
+        </p:spPr>
+        <p:txBody>
+          <a:bodyPr wrap="square">
+            <a:spAutoFit/>
+          </a:bodyPr>
+          <a:lstStyle/>
+          <a:p>
+            <a:pPr algn="ctr"/>
+            <a:r>
+              <a:rPr sz="2000" b="0" i="0">
+                <a:solidFill>
+                  <a:srgbClr val="FFFFFF"/>
+                </a:solidFill>
+                <a:latin typeface="Calibri"/>
+              </a:rPr>
+              <a:t>Software Engineering  |  Group Assignment 2</a:t>
             </a:r>
           </a:p>
         </p:txBody>
@@ -21240,41 +21240,6 @@
       <p:sp>
         <p:nvSpPr>
           <p:cNvPr id="11" name="TextBox 10"/>
-          <p:cNvSpPr txBox="1"/>
-          <p:nvPr/>
-        </p:nvSpPr>
-        <p:spPr>
-          <a:xfrm>
-            <a:off x="365760" y="3200400"/>
-            <a:ext cx="11430000" cy="411480"/>
-          </a:xfrm>
-          <a:prstGeom prst="rect">
-            <a:avLst/>
-          </a:prstGeom>
-          <a:noFill/>
-        </p:spPr>
-        <p:txBody>
-          <a:bodyPr wrap="square">
-            <a:spAutoFit/>
-          </a:bodyPr>
-          <a:lstStyle/>
-          <a:p>
-            <a:pPr algn="ctr"/>
-            <a:r>
-              <a:rPr sz="1600" b="0" i="0">
-                <a:solidFill>
-                  <a:srgbClr val="FFFFFF"/>
-                </a:solidFill>
-                <a:latin typeface="Calibri"/>
-              </a:rPr>
-              <a:t>[Student 1] — Waterfall &amp; Spiral Models  |  [Student 2] — Agile &amp; Comparative Analysis  |  [Student 3] — Team Roles</a:t>
-            </a:r>
-          </a:p>
-        </p:txBody>
-      </p:sp>
-      <p:sp>
-        <p:nvSpPr>
-          <p:cNvPr id="12" name="TextBox 11"/>
           <p:cNvSpPr txBox="1"/>
           <p:nvPr/>
         </p:nvSpPr>
@@ -21309,7 +21274,7 @@
       </p:sp>
       <p:sp>
         <p:nvSpPr>
-          <p:cNvPr id="13" name="TextBox 12"/>
+          <p:cNvPr id="12" name="TextBox 11"/>
           <p:cNvSpPr txBox="1"/>
           <p:nvPr/>
         </p:nvSpPr>
@@ -21344,7 +21309,7 @@
       </p:sp>
       <p:sp>
         <p:nvSpPr>
-          <p:cNvPr id="14" name="Rectangle 13"/>
+          <p:cNvPr id="13" name="Rectangle 12"/>
           <p:cNvSpPr/>
           <p:nvPr/>
         </p:nvSpPr>
@@ -21387,7 +21352,7 @@
       </p:sp>
       <p:sp>
         <p:nvSpPr>
-          <p:cNvPr id="15" name="TextBox 14"/>
+          <p:cNvPr id="14" name="TextBox 13"/>
           <p:cNvSpPr txBox="1"/>
           <p:nvPr/>
         </p:nvSpPr>

</xml_diff>